<commit_message>
add notes for pptx
</commit_message>
<xml_diff>
--- a/alpha_splice_hci_newest.pptx
+++ b/alpha_splice_hci_newest.pptx
@@ -129,7 +129,7 @@
   <p1510:revLst>
     <p1510:client id="{1D4EEA1F-FECD-4FF9-95CF-76C93672A27C}" v="11" dt="2026-04-30T00:35:04.080"/>
     <p1510:client id="{49560EDF-9CB9-41D1-9618-1748A9178868}" v="5" dt="2026-04-30T04:42:06.616"/>
-    <p1510:client id="{F199C9A7-F7C6-4FE4-A4AA-F33FA5989E97}" v="3" dt="2026-04-30T03:05:17.816"/>
+    <p1510:client id="{F199C9A7-F7C6-4FE4-A4AA-F33FA5989E97}" v="4" dt="2026-04-30T18:28:45.212"/>
   </p1510:revLst>
 </p1510:revInfo>
 </file>
@@ -184,7 +184,7 @@
   <pc:docChgLst>
     <pc:chgData name="N Z" userId="817a32b62f5c8f97" providerId="LiveId" clId="{91AFDEF6-9C5C-47EA-88B0-85AC90061651}"/>
     <pc:docChg chg="undo custSel modSld">
-      <pc:chgData name="N Z" userId="817a32b62f5c8f97" providerId="LiveId" clId="{91AFDEF6-9C5C-47EA-88B0-85AC90061651}" dt="2026-04-30T03:07:31.376" v="175" actId="20577"/>
+      <pc:chgData name="N Z" userId="817a32b62f5c8f97" providerId="LiveId" clId="{91AFDEF6-9C5C-47EA-88B0-85AC90061651}" dt="2026-04-30T18:30:07.974" v="398" actId="20577"/>
       <pc:docMkLst>
         <pc:docMk/>
       </pc:docMkLst>
@@ -341,6 +341,13 @@
             <ac:spMk id="10" creationId="{00000000-0000-0000-0000-000000000000}"/>
           </ac:spMkLst>
         </pc:spChg>
+      </pc:sldChg>
+      <pc:sldChg chg="modNotesTx">
+        <pc:chgData name="N Z" userId="817a32b62f5c8f97" providerId="LiveId" clId="{91AFDEF6-9C5C-47EA-88B0-85AC90061651}" dt="2026-04-30T18:30:07.974" v="398" actId="20577"/>
+        <pc:sldMkLst>
+          <pc:docMk/>
+          <pc:sldMk cId="0" sldId="263"/>
+        </pc:sldMkLst>
       </pc:sldChg>
       <pc:sldChg chg="modSp mod modNotesTx">
         <pc:chgData name="N Z" userId="817a32b62f5c8f97" providerId="LiveId" clId="{91AFDEF6-9C5C-47EA-88B0-85AC90061651}" dt="2026-04-30T02:25:49.234" v="106" actId="20577"/>
@@ -1804,6 +1811,21 @@
           <a:bodyPr/>
           <a:lstStyle/>
           <a:p>
+            <a:r>
+              <a:rPr lang="en-US" altLang="zh-CN" dirty="0"/>
+              <a:t>Here is the texture for a </a:t>
+            </a:r>
+            <a:r>
+              <a:rPr lang="en-US" altLang="zh-CN"/>
+              <a:t>character's garment</a:t>
+            </a:r>
+            <a:endParaRPr lang="en-US" altLang="zh-CN" dirty="0"/>
+          </a:p>
+          <a:p>
+            <a:r>
+              <a:rPr lang="en-US" altLang="zh-CN" dirty="0"/>
+              <a:t>And here is a new fabric scan(hex) we want to splice into part of it.</a:t>
+            </a:r>
             <a:endParaRPr lang="en-US" dirty="0"/>
           </a:p>
         </p:txBody>

</xml_diff>